<commit_message>
Update Auto-Rigging Insight Report - factual corrections (v2)
</commit_message>
<xml_diff>
--- a/Auto-Rigging-Insight-Report.pptx
+++ b/Auto-Rigging-Insight-Report.pptx
@@ -4294,7 +4294,7 @@
               </a:defRPr>
             </a:pPr>
             <a:r>
-              <a:t>● 架构：Geodesic GCN骨骼预测 + 神经网络蒙皮权重预测</a:t>
+              <a:t>● 架构：Point回归网络+Attention+MeanShift + GCN骨骼连接 + 神经蒙皮</a:t>
             </a:r>
           </a:p>
           <a:p>
@@ -4619,15 +4619,15 @@
               </a:defRPr>
             </a:pPr>
             <a:r>
-              <a:t>PointNet++ 多尺度采样</a:t>
+              <a:t>Point MLP回归</a:t>
             </a:r>
             <a:br/>
             <a:r>
-              <a:t>→ 热图 H ∈ ℝ^(N×1)</a:t>
+              <a:t>+ Attention筛选</a:t>
             </a:r>
             <a:br/>
             <a:r>
-              <a:t>→ NMS → 候选关节集合</a:t>
+              <a:t>+ Mean Shift聚类</a:t>
             </a:r>
           </a:p>
         </p:txBody>
@@ -5386,7 +5386,7 @@
               </a:defRPr>
             </a:pPr>
             <a:r>
-              <a:t>● 蒙皮需手动刷权重：★★★☆☆</a:t>
+              <a:t>● 自动生成初始蒙皮，生产级需手动修正：★★★☆☆</a:t>
             </a:r>
           </a:p>
           <a:p>
@@ -5982,7 +5982,7 @@
               </a:defRPr>
             </a:pPr>
             <a:r>
-              <a:t>1. 模板匹配 (SMPL/SCAPE)</a:t>
+              <a:t>1. 参数化模型 (SMPL/SCAPE)</a:t>
             </a:r>
           </a:p>
         </p:txBody>
@@ -6086,7 +6086,7 @@
               </a:defRPr>
             </a:pPr>
             <a:r>
-              <a:t>● SMPL: β∈ℝ¹⁰体型 + θ∈ℿ关节旋转</a:t>
+              <a:t>● SMPL: 学习型参数化人体模型</a:t>
             </a:r>
           </a:p>
           <a:p>
@@ -6099,13 +6099,13 @@
               </a:spcAft>
               <a:defRPr sz="1100" b="0">
                 <a:solidFill>
-                  <a:srgbClr val="06D6A0"/>
-                </a:solidFill>
-                <a:latin typeface="Microsoft YaHei"/>
-              </a:defRPr>
-            </a:pPr>
-            <a:r>
-              <a:t>● 精度：对人形&lt;1cm误差</a:t>
+                  <a:srgbClr val="B0B0C0"/>
+                </a:solidFill>
+                <a:latin typeface="Microsoft YaHei"/>
+              </a:defRPr>
+            </a:pPr>
+            <a:r>
+              <a:t>● β∈ℝ¹⁰体型 + θ∈ℿ关节旋转</a:t>
             </a:r>
           </a:p>
           <a:p>
@@ -6124,7 +6124,7 @@
               </a:defRPr>
             </a:pPr>
             <a:r>
-              <a:t>● 速度：~10ms（矩阵乘法）</a:t>
+              <a:t>● 精度：对人形&lt;1cm误差</a:t>
             </a:r>
           </a:p>
           <a:p>
@@ -6137,13 +6137,13 @@
               </a:spcAft>
               <a:defRPr sz="1100" b="0">
                 <a:solidFill>
-                  <a:srgbClr val="FF4444"/>
-                </a:solidFill>
-                <a:latin typeface="Microsoft YaHei"/>
-              </a:defRPr>
-            </a:pPr>
-            <a:r>
-              <a:t>● 局限：仅限人形，需注册对齐</a:t>
+                  <a:srgbClr val="06D6A0"/>
+                </a:solidFill>
+                <a:latin typeface="Microsoft YaHei"/>
+              </a:defRPr>
+            </a:pPr>
+            <a:r>
+              <a:t>● 速度：~10ms（矩阵乘法）</a:t>
             </a:r>
           </a:p>
           <a:p>
@@ -6156,13 +6156,13 @@
               </a:spcAft>
               <a:defRPr sz="1100" b="0">
                 <a:solidFill>
-                  <a:srgbClr val="707088"/>
-                </a:solidFill>
-                <a:latin typeface="Microsoft YaHei"/>
-              </a:defRPr>
-            </a:pPr>
-            <a:r>
-              <a:t>代表：SMPL, SCAPE, Mixamo</a:t>
+                  <a:srgbClr val="FF4444"/>
+                </a:solidFill>
+                <a:latin typeface="Microsoft YaHei"/>
+              </a:defRPr>
+            </a:pPr>
+            <a:r>
+              <a:t>● 局限：仅限人形，需注册对齐</a:t>
             </a:r>
           </a:p>
         </p:txBody>
@@ -6458,13 +6458,13 @@
               </a:spcAft>
               <a:defRPr sz="1100" b="0">
                 <a:solidFill>
-                  <a:srgbClr val="707088"/>
-                </a:solidFill>
-                <a:latin typeface="Microsoft YaHei"/>
-              </a:defRPr>
-            </a:pPr>
-            <a:r>
-              <a:t>代表：Au et al. 2008, QMAT</a:t>
+                  <a:srgbClr val="B0B0C0"/>
+                </a:solidFill>
+                <a:latin typeface="Microsoft YaHei"/>
+              </a:defRPr>
+            </a:pPr>
+            <a:r>
+              <a:t>● Crane et al.: "Geodesics in Heat" (SIGGRAPH 2013)</a:t>
             </a:r>
           </a:p>
         </p:txBody>
@@ -6671,7 +6671,7 @@
               </a:defRPr>
             </a:pPr>
             <a:r>
-              <a:t>● PointNet++ → 关节热图 → NMS</a:t>
+              <a:t>● Point MLP回归 → Attention → Mean Shift聚类 → 候选关节</a:t>
             </a:r>
           </a:p>
           <a:p>
@@ -7421,7 +7421,7 @@
         </p:nvGraphicFramePr>
         <p:xfrm>
           <a:off x="365760" y="4937760"/>
-          <a:ext cx="11430000" cy="1920240"/>
+          <a:ext cx="11430000" cy="2240280"/>
         </p:xfrm>
         <a:graphic>
           <a:graphicData uri="http://schemas.openxmlformats.org/drawingml/2006/table">
@@ -7623,7 +7623,7 @@
                         </a:defRPr>
                       </a:pPr>
                       <a:r>
-                        <a:t>模板匹配</a:t>
+                        <a:t>参数化模型</a:t>
                       </a:r>
                     </a:p>
                   </a:txBody>
@@ -7963,7 +7963,7 @@
                         </a:defRPr>
                       </a:pPr>
                       <a:r>
-                        <a:t>RigNet(DL)</a:t>
+                        <a:t>Pinocchio(经典)</a:t>
                       </a:r>
                     </a:p>
                   </a:txBody>
@@ -7987,7 +7987,7 @@
                         </a:defRPr>
                       </a:pPr>
                       <a:r>
-                        <a:t>★★★★☆</a:t>
+                        <a:t>★★★☆☆</a:t>
                       </a:r>
                     </a:p>
                   </a:txBody>
@@ -8035,7 +8035,7 @@
                         </a:defRPr>
                       </a:pPr>
                       <a:r>
-                        <a:t>★★★★☆</a:t>
+                        <a:t>★★★☆☆</a:t>
                       </a:r>
                     </a:p>
                   </a:txBody>
@@ -8059,7 +8059,7 @@
                         </a:defRPr>
                       </a:pPr>
                       <a:r>
-                        <a:t>高</a:t>
+                        <a:t>无</a:t>
                       </a:r>
                     </a:p>
                   </a:txBody>
@@ -8083,7 +8083,7 @@
                         </a:defRPr>
                       </a:pPr>
                       <a:r>
-                        <a:t>★★★★☆</a:t>
+                        <a:t>★★★★★</a:t>
                       </a:r>
                     </a:p>
                   </a:txBody>
@@ -8107,7 +8107,7 @@
                         </a:defRPr>
                       </a:pPr>
                       <a:r>
-                        <a:t>通用角色</a:t>
+                        <a:t>人形快速</a:t>
                       </a:r>
                     </a:p>
                   </a:txBody>
@@ -8133,7 +8133,7 @@
                         </a:defRPr>
                       </a:pPr>
                       <a:r>
-                        <a:t>热图方法</a:t>
+                        <a:t>RigNet(DL)</a:t>
                       </a:r>
                     </a:p>
                   </a:txBody>
@@ -8181,7 +8181,7 @@
                         </a:defRPr>
                       </a:pPr>
                       <a:r>
-                        <a:t>★★★☆☆</a:t>
+                        <a:t>★★★★☆</a:t>
                       </a:r>
                     </a:p>
                   </a:txBody>
@@ -8205,7 +8205,7 @@
                         </a:defRPr>
                       </a:pPr>
                       <a:r>
-                        <a:t>★★★☆☆</a:t>
+                        <a:t>★★★★☆</a:t>
                       </a:r>
                     </a:p>
                   </a:txBody>
@@ -8253,7 +8253,7 @@
                         </a:defRPr>
                       </a:pPr>
                       <a:r>
-                        <a:t>★★★☆☆</a:t>
+                        <a:t>★★★★☆</a:t>
                       </a:r>
                     </a:p>
                   </a:txBody>
@@ -8277,7 +8277,7 @@
                         </a:defRPr>
                       </a:pPr>
                       <a:r>
-                        <a:t>人形/四足</a:t>
+                        <a:t>通用角色</a:t>
                       </a:r>
                     </a:p>
                   </a:txBody>
@@ -8303,7 +8303,7 @@
                         </a:defRPr>
                       </a:pPr>
                       <a:r>
-                        <a:t>GNN方法</a:t>
+                        <a:t>热图方法</a:t>
                       </a:r>
                     </a:p>
                   </a:txBody>
@@ -8375,7 +8375,7 @@
                         </a:defRPr>
                       </a:pPr>
                       <a:r>
-                        <a:t>★★★★☆</a:t>
+                        <a:t>★★★☆☆</a:t>
                       </a:r>
                     </a:p>
                   </a:txBody>
@@ -8399,7 +8399,7 @@
                         </a:defRPr>
                       </a:pPr>
                       <a:r>
-                        <a:t>中</a:t>
+                        <a:t>高</a:t>
                       </a:r>
                     </a:p>
                   </a:txBody>
@@ -8447,13 +8447,183 @@
                         </a:defRPr>
                       </a:pPr>
                       <a:r>
+                        <a:t>人形/四足</a:t>
+                      </a:r>
+                    </a:p>
+                  </a:txBody>
+                  <a:tcPr>
+                    <a:solidFill>
+                      <a:srgbClr val="0F3460"/>
+                    </a:solidFill>
+                  </a:tcPr>
+                </a:tc>
+              </a:tr>
+              <a:tr h="320040">
+                <a:tc>
+                  <a:txBody>
+                    <a:bodyPr/>
+                    <a:lstStyle/>
+                    <a:p>
+                      <a:pPr algn="l">
+                        <a:defRPr sz="1000">
+                          <a:solidFill>
+                            <a:srgbClr val="FFFFFF"/>
+                          </a:solidFill>
+                          <a:latin typeface="Microsoft YaHei"/>
+                        </a:defRPr>
+                      </a:pPr>
+                      <a:r>
+                        <a:t>GNN方法</a:t>
+                      </a:r>
+                    </a:p>
+                  </a:txBody>
+                  <a:tcPr>
+                    <a:solidFill>
+                      <a:srgbClr val="10182E"/>
+                    </a:solidFill>
+                  </a:tcPr>
+                </a:tc>
+                <a:tc>
+                  <a:txBody>
+                    <a:bodyPr/>
+                    <a:lstStyle/>
+                    <a:p>
+                      <a:pPr algn="l">
+                        <a:defRPr sz="1000">
+                          <a:solidFill>
+                            <a:srgbClr val="FFFFFF"/>
+                          </a:solidFill>
+                          <a:latin typeface="Microsoft YaHei"/>
+                        </a:defRPr>
+                      </a:pPr>
+                      <a:r>
+                        <a:t>★★★★☆</a:t>
+                      </a:r>
+                    </a:p>
+                  </a:txBody>
+                  <a:tcPr>
+                    <a:solidFill>
+                      <a:srgbClr val="10182E"/>
+                    </a:solidFill>
+                  </a:tcPr>
+                </a:tc>
+                <a:tc>
+                  <a:txBody>
+                    <a:bodyPr/>
+                    <a:lstStyle/>
+                    <a:p>
+                      <a:pPr algn="l">
+                        <a:defRPr sz="1000">
+                          <a:solidFill>
+                            <a:srgbClr val="FFFFFF"/>
+                          </a:solidFill>
+                          <a:latin typeface="Microsoft YaHei"/>
+                        </a:defRPr>
+                      </a:pPr>
+                      <a:r>
+                        <a:t>★★★☆☆</a:t>
+                      </a:r>
+                    </a:p>
+                  </a:txBody>
+                  <a:tcPr>
+                    <a:solidFill>
+                      <a:srgbClr val="10182E"/>
+                    </a:solidFill>
+                  </a:tcPr>
+                </a:tc>
+                <a:tc>
+                  <a:txBody>
+                    <a:bodyPr/>
+                    <a:lstStyle/>
+                    <a:p>
+                      <a:pPr algn="l">
+                        <a:defRPr sz="1000">
+                          <a:solidFill>
+                            <a:srgbClr val="FFFFFF"/>
+                          </a:solidFill>
+                          <a:latin typeface="Microsoft YaHei"/>
+                        </a:defRPr>
+                      </a:pPr>
+                      <a:r>
+                        <a:t>★★★★☆</a:t>
+                      </a:r>
+                    </a:p>
+                  </a:txBody>
+                  <a:tcPr>
+                    <a:solidFill>
+                      <a:srgbClr val="10182E"/>
+                    </a:solidFill>
+                  </a:tcPr>
+                </a:tc>
+                <a:tc>
+                  <a:txBody>
+                    <a:bodyPr/>
+                    <a:lstStyle/>
+                    <a:p>
+                      <a:pPr algn="l">
+                        <a:defRPr sz="1000">
+                          <a:solidFill>
+                            <a:srgbClr val="FFFFFF"/>
+                          </a:solidFill>
+                          <a:latin typeface="Microsoft YaHei"/>
+                        </a:defRPr>
+                      </a:pPr>
+                      <a:r>
+                        <a:t>中</a:t>
+                      </a:r>
+                    </a:p>
+                  </a:txBody>
+                  <a:tcPr>
+                    <a:solidFill>
+                      <a:srgbClr val="10182E"/>
+                    </a:solidFill>
+                  </a:tcPr>
+                </a:tc>
+                <a:tc>
+                  <a:txBody>
+                    <a:bodyPr/>
+                    <a:lstStyle/>
+                    <a:p>
+                      <a:pPr algn="l">
+                        <a:defRPr sz="1000">
+                          <a:solidFill>
+                            <a:srgbClr val="FFFFFF"/>
+                          </a:solidFill>
+                          <a:latin typeface="Microsoft YaHei"/>
+                        </a:defRPr>
+                      </a:pPr>
+                      <a:r>
+                        <a:t>★★★☆☆</a:t>
+                      </a:r>
+                    </a:p>
+                  </a:txBody>
+                  <a:tcPr>
+                    <a:solidFill>
+                      <a:srgbClr val="10182E"/>
+                    </a:solidFill>
+                  </a:tcPr>
+                </a:tc>
+                <a:tc>
+                  <a:txBody>
+                    <a:bodyPr/>
+                    <a:lstStyle/>
+                    <a:p>
+                      <a:pPr algn="l">
+                        <a:defRPr sz="1000">
+                          <a:solidFill>
+                            <a:srgbClr val="FFFFFF"/>
+                          </a:solidFill>
+                          <a:latin typeface="Microsoft YaHei"/>
+                        </a:defRPr>
+                      </a:pPr>
+                      <a:r>
                         <a:t>拓扑感知</a:t>
                       </a:r>
                     </a:p>
                   </a:txBody>
                   <a:tcPr>
                     <a:solidFill>
-                      <a:srgbClr val="0F3460"/>
+                      <a:srgbClr val="10182E"/>
                     </a:solidFill>
                   </a:tcPr>
                 </a:tc>
@@ -11983,7 +12153,7 @@
               </a:defRPr>
             </a:pPr>
             <a:r>
-              <a:t>vs PointNet++: 全局建模更强</a:t>
+              <a:t>vs Point MLP: 全局建模更强</a:t>
             </a:r>
           </a:p>
           <a:p>
@@ -12295,13 +12465,13 @@
               </a:spcAft>
               <a:defRPr sz="1100" b="0">
                 <a:solidFill>
-                  <a:srgbClr val="00B4D8"/>
-                </a:solidFill>
-                <a:latin typeface="Microsoft YaHei"/>
-              </a:defRPr>
-            </a:pPr>
-            <a:r>
-              <a:t>RigNet骨干网络：4层SA + 4层FP</a:t>
+                  <a:srgbClr val="FFC107"/>
+                </a:solidFill>
+                <a:latin typeface="Microsoft YaHei"/>
+              </a:defRPr>
+            </a:pPr>
+            <a:r>
+              <a:t>3D点云处理的基础架构（注：RigNet未使用）</a:t>
             </a:r>
           </a:p>
           <a:p>
@@ -18246,17 +18416,6 @@
                         <a:t>AI+规则</a:t>
                       </a:r>
                     </a:p>
-                  </a:txBody>
-                  <a:tcPr>
-                    <a:solidFill>
-                      <a:srgbClr val="10182E"/>
-                    </a:solidFill>
-                  </a:tcPr>
-                </a:tc>
-                <a:tc>
-                  <a:txBody>
-                    <a:bodyPr/>
-                    <a:lstStyle/>
                     <a:p>
                       <a:pPr algn="l">
                         <a:defRPr sz="1000">
@@ -18267,7 +18426,7 @@
                         </a:defRPr>
                       </a:pPr>
                       <a:r>
-                        <a:t>✓</a:t>
+                        <a:t>(Stanford)</a:t>
                       </a:r>
                     </a:p>
                   </a:txBody>
@@ -18291,7 +18450,7 @@
                         </a:defRPr>
                       </a:pPr>
                       <a:r>
-                        <a:t>✗</a:t>
+                        <a:t>✓</a:t>
                       </a:r>
                     </a:p>
                   </a:txBody>
@@ -18339,7 +18498,7 @@
                         </a:defRPr>
                       </a:pPr>
                       <a:r>
-                        <a:t>★★★★☆</a:t>
+                        <a:t>✗</a:t>
                       </a:r>
                     </a:p>
                   </a:txBody>
@@ -18387,7 +18546,7 @@
                         </a:defRPr>
                       </a:pPr>
                       <a:r>
-                        <a:t>分钟</a:t>
+                        <a:t>★★★★☆</a:t>
                       </a:r>
                     </a:p>
                   </a:txBody>
@@ -18411,7 +18570,7 @@
                         </a:defRPr>
                       </a:pPr>
                       <a:r>
-                        <a:t>低</a:t>
+                        <a:t>分钟</a:t>
                       </a:r>
                     </a:p>
                   </a:txBody>
@@ -18435,7 +18594,31 @@
                         </a:defRPr>
                       </a:pPr>
                       <a:r>
-                        <a:t>免费</a:t>
+                        <a:t>低</a:t>
+                      </a:r>
+                    </a:p>
+                  </a:txBody>
+                  <a:tcPr>
+                    <a:solidFill>
+                      <a:srgbClr val="10182E"/>
+                    </a:solidFill>
+                  </a:tcPr>
+                </a:tc>
+                <a:tc>
+                  <a:txBody>
+                    <a:bodyPr/>
+                    <a:lstStyle/>
+                    <a:p>
+                      <a:pPr algn="l">
+                        <a:defRPr sz="1000">
+                          <a:solidFill>
+                            <a:srgbClr val="FFFFFF"/>
+                          </a:solidFill>
+                          <a:latin typeface="Microsoft YaHei"/>
+                        </a:defRPr>
+                      </a:pPr>
+                      <a:r>
+                        <a:t>免费*</a:t>
                       </a:r>
                     </a:p>
                   </a:txBody>
@@ -19776,7 +19959,7 @@
               </a:defRPr>
             </a:pPr>
             <a:r>
-              <a:t>● 纯AI端到端，通用骨骼支持</a:t>
+              <a:t>● 端到端：关节预测+骨骼连接+蒙皮</a:t>
             </a:r>
           </a:p>
           <a:p>
@@ -19795,7 +19978,7 @@
               </a:defRPr>
             </a:pPr>
             <a:r>
-              <a:t>● 开源可用，学术影响力最大</a:t>
+              <a:t>● 通用骨骼支持（不限人形）</a:t>
             </a:r>
           </a:p>
           <a:p>
@@ -19814,7 +19997,7 @@
               </a:defRPr>
             </a:pPr>
             <a:r>
-              <a:t>● 最适合高校合作研究起点</a:t>
+              <a:t>● 开源代码，学术影响力最大</a:t>
             </a:r>
           </a:p>
           <a:p>
@@ -20483,7 +20666,7 @@
               </a:defRPr>
             </a:pPr>
             <a:r>
-              <a:t>🏆 综合推荐 — AI混合方案</a:t>
+              <a:t>🏆 综合推荐 — 分层策略</a:t>
             </a:r>
           </a:p>
         </p:txBody>
@@ -20568,7 +20751,7 @@
               </a:defRPr>
             </a:pPr>
             <a:r>
-              <a:t>● 骨骼：改进RigNet (Transformer)</a:t>
+              <a:t>● 快速人形: Mixamo (免费即用)</a:t>
             </a:r>
           </a:p>
           <a:p>
@@ -20587,7 +20770,7 @@
               </a:defRPr>
             </a:pPr>
             <a:r>
-              <a:t>● 蒙皮：DL+GVB混合</a:t>
+              <a:t>● 生产级: UE5 ML Deformer</a:t>
             </a:r>
           </a:p>
           <a:p>
@@ -20606,7 +20789,7 @@
               </a:defRPr>
             </a:pPr>
             <a:r>
-              <a:t>● 引擎集成：UE5 ML Deformer</a:t>
+              <a:t>● 科研通用: 改进RigNet+DL蒙皮</a:t>
             </a:r>
           </a:p>
           <a:p>
@@ -20625,14 +20808,50 @@
               </a:defRPr>
             </a:pPr>
             <a:r>
-              <a:t>● 通用化：扩散模型+元学习</a:t>
-            </a:r>
-          </a:p>
-        </p:txBody>
-      </p:sp>
-      <p:sp>
-        <p:nvSpPr>
-          <p:cNvPr id="28" name="Rectangle 27"/>
+              <a:t>● 前沿: 扩散模型+元学习预研</a:t>
+            </a:r>
+          </a:p>
+        </p:txBody>
+      </p:sp>
+      <p:sp>
+        <p:nvSpPr>
+          <p:cNvPr id="28" name="TextBox 27"/>
+          <p:cNvSpPr txBox="1"/>
+          <p:nvPr/>
+        </p:nvSpPr>
+        <p:spPr>
+          <a:xfrm>
+            <a:off x="274320" y="6400800"/>
+            <a:ext cx="11430000" cy="274320"/>
+          </a:xfrm>
+          <a:prstGeom prst="rect">
+            <a:avLst/>
+          </a:prstGeom>
+          <a:noFill/>
+        </p:spPr>
+        <p:txBody>
+          <a:bodyPr wrap="square">
+            <a:spAutoFit/>
+          </a:bodyPr>
+          <a:lstStyle/>
+          <a:p>
+            <a:pPr algn="l">
+              <a:defRPr sz="900" b="0">
+                <a:solidFill>
+                  <a:srgbClr val="707088"/>
+                </a:solidFill>
+                <a:latin typeface="Microsoft YaHei"/>
+              </a:defRPr>
+            </a:pPr>
+            <a:r>
+              <a:t>* Mixamo免费使用需注册Adobe ID  |  Pinocchio (SIGGRAPH 2007) 是自动绑定经典先驱  |  MetaHuman为UE5参数化人体方案</a:t>
+            </a:r>
+          </a:p>
+        </p:txBody>
+      </p:sp>
+      <p:sp>
+        <p:nvSpPr>
+          <p:cNvPr id="29" name="Rectangle 28"/>
           <p:cNvSpPr/>
           <p:nvPr/>
         </p:nvSpPr>
@@ -20675,7 +20894,7 @@
       </p:sp>
       <p:sp>
         <p:nvSpPr>
-          <p:cNvPr id="29" name="TextBox 28"/>
+          <p:cNvPr id="30" name="TextBox 29"/>
           <p:cNvSpPr txBox="1"/>
           <p:nvPr/>
         </p:nvSpPr>
@@ -20924,7 +21143,7 @@
               </a:defRPr>
             </a:pPr>
             <a:r>
-              <a:t>▎推荐方案：改进RigNet + 混合蒙皮 + UE5集成</a:t>
+              <a:t>▎推荐方案：改进RigNet + DL/GVB混合蒙皮 + UE5集成</a:t>
             </a:r>
           </a:p>
         </p:txBody>
@@ -21240,7 +21459,7 @@
               </a:defRPr>
             </a:pPr>
             <a:r>
-              <a:t>PointNet++</a:t>
+              <a:t>Point MLP</a:t>
             </a:r>
             <a:br/>
             <a:r>
@@ -21363,11 +21582,11 @@
               </a:defRPr>
             </a:pPr>
             <a:r>
-              <a:t>关节热图</a:t>
+              <a:t>关节候选</a:t>
             </a:r>
             <a:br/>
             <a:r>
-              <a:t>+ NMS</a:t>
+              <a:t>+ Mean Shift</a:t>
             </a:r>
           </a:p>
         </p:txBody>
@@ -21486,7 +21705,7 @@
             </a:r>
             <a:br/>
             <a:r>
-              <a:t>MST+GNN</a:t>
+              <a:t>GCN+RootNet</a:t>
             </a:r>
           </a:p>
         </p:txBody>
@@ -23003,7 +23222,7 @@
               </a:defRPr>
             </a:pPr>
             <a:r>
-              <a:t>核心优势：① RigNet+Transformer提升骨骼泛化能力  ② DL+GVB混合蒙皮兼顾精度和鲁棒性  ③ UE5 ML Deformer保证影视级质量  ④ 扩散模型预研面向通用化未来</a:t>
+              <a:t>核心优势：① 改进RigNet+Transformer提升骨骼泛化能力  ② DL+GVB混合蒙皮兼顾精度和鲁棒性  ③ UE5 ML Deformer保证影视级质量  ④ 扩散模型预研面向通用化未来  *注：RigNet使用自定义Point MLP+Attention+MeanShift，非PointNet++</a:t>
             </a:r>
           </a:p>
         </p:txBody>
@@ -23546,7 +23765,7 @@
               </a:defRPr>
             </a:pPr>
             <a:r>
-              <a:t>● 改进RigNet → Point Transformer V3骨干</a:t>
+              <a:t>● 改进RigNet → Point Transformer V3替代原始MLP骨干</a:t>
             </a:r>
           </a:p>
           <a:p>
@@ -24820,7 +25039,7 @@
               </a:defRPr>
             </a:pPr>
             <a:r>
-              <a:t>核心思路：以RigNet为基线，引入Transformer/GNN/扩散模型等前沿技术，实现通用化+高质量+实时化的突破</a:t>
+              <a:t>核心思路：以RigNet为基线（其使用自定义MLP+Attention+MeanShift+GCN架构），引入Transformer/GNN/扩散模型等前沿技术，实现通用化+高质量+实时化的突破</a:t>
             </a:r>
           </a:p>
         </p:txBody>
@@ -30954,7 +31173,7 @@
               </a:defRPr>
             </a:pPr>
             <a:r>
-              <a:t>AI驱动（RigNet+Transformer）是最佳方向，混合方案（DL+几何）保证质量</a:t>
+              <a:t>AI驱动（RigNet改进+Transformer）是最佳方向，DL+几何混合方案保证质量</a:t>
             </a:r>
           </a:p>
         </p:txBody>
@@ -36498,7 +36717,7 @@
               </a:defRPr>
             </a:pPr>
             <a:r>
-              <a:t>UE5 ML Deformer</a:t>
+              <a:t>UE5 ML Deformer / MetaHuman</a:t>
             </a:r>
           </a:p>
         </p:txBody>
@@ -36814,7 +37033,7 @@
               </a:defRPr>
             </a:pPr>
             <a:r>
-              <a:t>Mixamo (Adobe)</a:t>
+              <a:t>Mixamo (Adobe/Stanford)</a:t>
             </a:r>
           </a:p>
         </p:txBody>
@@ -36893,7 +37112,7 @@
               </a:defRPr>
             </a:pPr>
             <a:r>
-              <a:t>RigNet (学术标杆)</a:t>
+              <a:t>RigNet (SIGGRAPH 2020 学术标杆)</a:t>
             </a:r>
           </a:p>
         </p:txBody>
@@ -37051,7 +37270,7 @@
               </a:defRPr>
             </a:pPr>
             <a:r>
-              <a:t>网易伏羲 / GoSkinning</a:t>
+              <a:t>网易伏羲 / GoSkinning / AccuRIG</a:t>
             </a:r>
           </a:p>
         </p:txBody>
@@ -37155,7 +37374,7 @@
                         </a:defRPr>
                       </a:pPr>
                       <a:r>
-                        <a:t>规则/模板匹配</a:t>
+                        <a:t>参数化模型/规则</a:t>
                       </a:r>
                     </a:p>
                   </a:txBody>
@@ -37253,7 +37472,7 @@
                         </a:defRPr>
                       </a:pPr>
                       <a:r>
-                        <a:t>Maya HumanIK / Mixamo</a:t>
+                        <a:t>Maya HumanIK / SMPL / Mixamo</a:t>
                       </a:r>
                     </a:p>
                   </a:txBody>
@@ -38652,7 +38871,7 @@
               </a:defRPr>
             </a:pPr>
             <a:r>
-              <a:t>● 体素空间测地距离计算蒙皮权重</a:t>
+              <a:t>● 网格体素化后测地距离计算蒙皮权重</a:t>
             </a:r>
           </a:p>
           <a:p>
@@ -38665,13 +38884,13 @@
               </a:spcAft>
               <a:defRPr sz="1100" b="0">
                 <a:solidFill>
-                  <a:srgbClr val="FFFFFF"/>
-                </a:solidFill>
-                <a:latin typeface="Microsoft YaHei"/>
-              </a:defRPr>
-            </a:pPr>
-            <a:r>
-              <a:t>● 解决表面拓扑噪声问题</a:t>
+                  <a:srgbClr val="B0B0C0"/>
+                </a:solidFill>
+                <a:latin typeface="Microsoft YaHei"/>
+              </a:defRPr>
+            </a:pPr>
+            <a:r>
+              <a:t>● Dionne &amp; de Lasa: "Geodesic Voxel Binding for Thin Structures"</a:t>
             </a:r>
           </a:p>
           <a:p>
@@ -38690,7 +38909,7 @@
               </a:defRPr>
             </a:pPr>
             <a:r>
-              <a:t>● 质量远超传统Heat Map</a:t>
+              <a:t>● 解决表面拓扑噪声和薄壁穿透问题</a:t>
             </a:r>
           </a:p>
           <a:p>
@@ -38703,13 +38922,13 @@
               </a:spcAft>
               <a:defRPr sz="1100" b="0">
                 <a:solidFill>
-                  <a:srgbClr val="FFC107"/>
-                </a:solidFill>
-                <a:latin typeface="Microsoft YaHei"/>
-              </a:defRPr>
-            </a:pPr>
-            <a:r>
-              <a:t>● 蒙皮质量：★★★★☆</a:t>
+                  <a:srgbClr val="FFFFFF"/>
+                </a:solidFill>
+                <a:latin typeface="Microsoft YaHei"/>
+              </a:defRPr>
+            </a:pPr>
+            <a:r>
+              <a:t>● 质量远超传统Heat Map</a:t>
             </a:r>
           </a:p>
           <a:p>
@@ -38722,203 +38941,15 @@
               </a:spcAft>
               <a:defRPr sz="1100" b="0">
                 <a:solidFill>
-                  <a:srgbClr val="707088"/>
-                </a:solidFill>
-                <a:latin typeface="Microsoft YaHei"/>
-              </a:defRPr>
-            </a:pPr>
-            <a:r>
-              <a:t>● 处理速度：数秒-数十秒</a:t>
-            </a:r>
-          </a:p>
-        </p:txBody>
-      </p:sp>
-      <p:sp>
-        <p:nvSpPr>
-          <p:cNvPr id="16" name="Rounded Rectangle 15"/>
-          <p:cNvSpPr/>
-          <p:nvPr/>
-        </p:nvSpPr>
-        <p:spPr>
-          <a:xfrm>
-            <a:off x="8046720" y="1371600"/>
-            <a:ext cx="3611880" cy="2468880"/>
-          </a:xfrm>
-          <a:prstGeom prst="roundRect">
-            <a:avLst/>
-          </a:prstGeom>
-          <a:solidFill>
-            <a:srgbClr val="10182E"/>
-          </a:solidFill>
-          <a:ln>
-            <a:noFill/>
-          </a:ln>
-        </p:spPr>
-        <p:style>
-          <a:lnRef idx="1">
-            <a:schemeClr val="accent1"/>
-          </a:lnRef>
-          <a:fillRef idx="3">
-            <a:schemeClr val="accent1"/>
-          </a:fillRef>
-          <a:effectRef idx="2">
-            <a:schemeClr val="accent1"/>
-          </a:effectRef>
-          <a:fontRef idx="minor">
-            <a:schemeClr val="lt1"/>
-          </a:fontRef>
-        </p:style>
-        <p:txBody>
-          <a:bodyPr rtlCol="0" anchor="ctr"/>
-          <a:lstStyle/>
-          <a:p>
-            <a:pPr algn="ctr"/>
-          </a:p>
-        </p:txBody>
-      </p:sp>
-      <p:sp>
-        <p:nvSpPr>
-          <p:cNvPr id="17" name="Rectangle 16"/>
-          <p:cNvSpPr/>
-          <p:nvPr/>
-        </p:nvSpPr>
-        <p:spPr>
-          <a:xfrm>
-            <a:off x="8138160" y="1371600"/>
-            <a:ext cx="3429000" cy="36576"/>
-          </a:xfrm>
-          <a:prstGeom prst="rect">
-            <a:avLst/>
-          </a:prstGeom>
-          <a:solidFill>
-            <a:srgbClr val="00B4D8"/>
-          </a:solidFill>
-          <a:ln>
-            <a:noFill/>
-          </a:ln>
-        </p:spPr>
-        <p:style>
-          <a:lnRef idx="1">
-            <a:schemeClr val="accent1"/>
-          </a:lnRef>
-          <a:fillRef idx="3">
-            <a:schemeClr val="accent1"/>
-          </a:fillRef>
-          <a:effectRef idx="2">
-            <a:schemeClr val="accent1"/>
-          </a:effectRef>
-          <a:fontRef idx="minor">
-            <a:schemeClr val="lt1"/>
-          </a:fontRef>
-        </p:style>
-        <p:txBody>
-          <a:bodyPr rtlCol="0" anchor="ctr"/>
-          <a:lstStyle/>
-          <a:p>
-            <a:pPr algn="ctr"/>
-          </a:p>
-        </p:txBody>
-      </p:sp>
-      <p:sp>
-        <p:nvSpPr>
-          <p:cNvPr id="18" name="TextBox 17"/>
-          <p:cNvSpPr txBox="1"/>
-          <p:nvPr/>
-        </p:nvSpPr>
-        <p:spPr>
-          <a:xfrm>
-            <a:off x="8183880" y="1463040"/>
-            <a:ext cx="3337560" cy="320040"/>
-          </a:xfrm>
-          <a:prstGeom prst="rect">
-            <a:avLst/>
-          </a:prstGeom>
-          <a:noFill/>
-        </p:spPr>
-        <p:txBody>
-          <a:bodyPr wrap="square">
-            <a:spAutoFit/>
-          </a:bodyPr>
-          <a:lstStyle/>
-          <a:p>
-            <a:pPr algn="l">
-              <a:defRPr sz="1400" b="1">
-                <a:solidFill>
-                  <a:srgbClr val="00B4D8"/>
-                </a:solidFill>
-                <a:latin typeface="Microsoft YaHei"/>
-              </a:defRPr>
-            </a:pPr>
-            <a:r>
-              <a:t>Quick Rig / mGear</a:t>
-            </a:r>
-          </a:p>
-        </p:txBody>
-      </p:sp>
-      <p:sp>
-        <p:nvSpPr>
-          <p:cNvPr id="19" name="Rectangle 18"/>
-          <p:cNvSpPr/>
-          <p:nvPr/>
-        </p:nvSpPr>
-        <p:spPr>
-          <a:xfrm>
-            <a:off x="8183880" y="1783080"/>
-            <a:ext cx="3337560" cy="9144"/>
-          </a:xfrm>
-          <a:prstGeom prst="rect">
-            <a:avLst/>
-          </a:prstGeom>
-          <a:solidFill>
-            <a:srgbClr val="303050"/>
-          </a:solidFill>
-          <a:ln>
-            <a:noFill/>
-          </a:ln>
-        </p:spPr>
-        <p:style>
-          <a:lnRef idx="1">
-            <a:schemeClr val="accent1"/>
-          </a:lnRef>
-          <a:fillRef idx="3">
-            <a:schemeClr val="accent1"/>
-          </a:fillRef>
-          <a:effectRef idx="2">
-            <a:schemeClr val="accent1"/>
-          </a:effectRef>
-          <a:fontRef idx="minor">
-            <a:schemeClr val="lt1"/>
-          </a:fontRef>
-        </p:style>
-        <p:txBody>
-          <a:bodyPr rtlCol="0" anchor="ctr"/>
-          <a:lstStyle/>
-          <a:p>
-            <a:pPr algn="ctr"/>
-          </a:p>
-        </p:txBody>
-      </p:sp>
-      <p:sp>
-        <p:nvSpPr>
-          <p:cNvPr id="20" name="TextBox 19"/>
-          <p:cNvSpPr txBox="1"/>
-          <p:nvPr/>
-        </p:nvSpPr>
-        <p:spPr>
-          <a:xfrm>
-            <a:off x="8183880" y="1828800"/>
-            <a:ext cx="3337560" cy="1965960"/>
-          </a:xfrm>
-          <a:prstGeom prst="rect">
-            <a:avLst/>
-          </a:prstGeom>
-          <a:noFill/>
-        </p:spPr>
-        <p:txBody>
-          <a:bodyPr wrap="square">
-            <a:spAutoFit/>
-          </a:bodyPr>
-          <a:lstStyle/>
+                  <a:srgbClr val="FFC107"/>
+                </a:solidFill>
+                <a:latin typeface="Microsoft YaHei"/>
+              </a:defRPr>
+            </a:pPr>
+            <a:r>
+              <a:t>● 蒙皮质量：★★★★☆</a:t>
+            </a:r>
+          </a:p>
           <a:p>
             <a:pPr algn="l">
               <a:lnSpc>
@@ -38929,15 +38960,203 @@
               </a:spcAft>
               <a:defRPr sz="1100" b="0">
                 <a:solidFill>
-                  <a:srgbClr val="FFFFFF"/>
-                </a:solidFill>
-                <a:latin typeface="Microsoft YaHei"/>
-              </a:defRPr>
-            </a:pPr>
-            <a:r>
-              <a:t>● Quick Rig：一键式人形自动绑定</a:t>
-            </a:r>
-          </a:p>
+                  <a:srgbClr val="707088"/>
+                </a:solidFill>
+                <a:latin typeface="Microsoft YaHei"/>
+              </a:defRPr>
+            </a:pPr>
+            <a:r>
+              <a:t>● 处理速度：数秒-数十秒</a:t>
+            </a:r>
+          </a:p>
+        </p:txBody>
+      </p:sp>
+      <p:sp>
+        <p:nvSpPr>
+          <p:cNvPr id="16" name="Rounded Rectangle 15"/>
+          <p:cNvSpPr/>
+          <p:nvPr/>
+        </p:nvSpPr>
+        <p:spPr>
+          <a:xfrm>
+            <a:off x="8046720" y="1371600"/>
+            <a:ext cx="3611880" cy="2468880"/>
+          </a:xfrm>
+          <a:prstGeom prst="roundRect">
+            <a:avLst/>
+          </a:prstGeom>
+          <a:solidFill>
+            <a:srgbClr val="10182E"/>
+          </a:solidFill>
+          <a:ln>
+            <a:noFill/>
+          </a:ln>
+        </p:spPr>
+        <p:style>
+          <a:lnRef idx="1">
+            <a:schemeClr val="accent1"/>
+          </a:lnRef>
+          <a:fillRef idx="3">
+            <a:schemeClr val="accent1"/>
+          </a:fillRef>
+          <a:effectRef idx="2">
+            <a:schemeClr val="accent1"/>
+          </a:effectRef>
+          <a:fontRef idx="minor">
+            <a:schemeClr val="lt1"/>
+          </a:fontRef>
+        </p:style>
+        <p:txBody>
+          <a:bodyPr rtlCol="0" anchor="ctr"/>
+          <a:lstStyle/>
+          <a:p>
+            <a:pPr algn="ctr"/>
+          </a:p>
+        </p:txBody>
+      </p:sp>
+      <p:sp>
+        <p:nvSpPr>
+          <p:cNvPr id="17" name="Rectangle 16"/>
+          <p:cNvSpPr/>
+          <p:nvPr/>
+        </p:nvSpPr>
+        <p:spPr>
+          <a:xfrm>
+            <a:off x="8138160" y="1371600"/>
+            <a:ext cx="3429000" cy="36576"/>
+          </a:xfrm>
+          <a:prstGeom prst="rect">
+            <a:avLst/>
+          </a:prstGeom>
+          <a:solidFill>
+            <a:srgbClr val="00B4D8"/>
+          </a:solidFill>
+          <a:ln>
+            <a:noFill/>
+          </a:ln>
+        </p:spPr>
+        <p:style>
+          <a:lnRef idx="1">
+            <a:schemeClr val="accent1"/>
+          </a:lnRef>
+          <a:fillRef idx="3">
+            <a:schemeClr val="accent1"/>
+          </a:fillRef>
+          <a:effectRef idx="2">
+            <a:schemeClr val="accent1"/>
+          </a:effectRef>
+          <a:fontRef idx="minor">
+            <a:schemeClr val="lt1"/>
+          </a:fontRef>
+        </p:style>
+        <p:txBody>
+          <a:bodyPr rtlCol="0" anchor="ctr"/>
+          <a:lstStyle/>
+          <a:p>
+            <a:pPr algn="ctr"/>
+          </a:p>
+        </p:txBody>
+      </p:sp>
+      <p:sp>
+        <p:nvSpPr>
+          <p:cNvPr id="18" name="TextBox 17"/>
+          <p:cNvSpPr txBox="1"/>
+          <p:nvPr/>
+        </p:nvSpPr>
+        <p:spPr>
+          <a:xfrm>
+            <a:off x="8183880" y="1463040"/>
+            <a:ext cx="3337560" cy="320040"/>
+          </a:xfrm>
+          <a:prstGeom prst="rect">
+            <a:avLst/>
+          </a:prstGeom>
+          <a:noFill/>
+        </p:spPr>
+        <p:txBody>
+          <a:bodyPr wrap="square">
+            <a:spAutoFit/>
+          </a:bodyPr>
+          <a:lstStyle/>
+          <a:p>
+            <a:pPr algn="l">
+              <a:defRPr sz="1400" b="1">
+                <a:solidFill>
+                  <a:srgbClr val="00B4D8"/>
+                </a:solidFill>
+                <a:latin typeface="Microsoft YaHei"/>
+              </a:defRPr>
+            </a:pPr>
+            <a:r>
+              <a:t>Quick Rig / mGear</a:t>
+            </a:r>
+          </a:p>
+        </p:txBody>
+      </p:sp>
+      <p:sp>
+        <p:nvSpPr>
+          <p:cNvPr id="19" name="Rectangle 18"/>
+          <p:cNvSpPr/>
+          <p:nvPr/>
+        </p:nvSpPr>
+        <p:spPr>
+          <a:xfrm>
+            <a:off x="8183880" y="1783080"/>
+            <a:ext cx="3337560" cy="9144"/>
+          </a:xfrm>
+          <a:prstGeom prst="rect">
+            <a:avLst/>
+          </a:prstGeom>
+          <a:solidFill>
+            <a:srgbClr val="303050"/>
+          </a:solidFill>
+          <a:ln>
+            <a:noFill/>
+          </a:ln>
+        </p:spPr>
+        <p:style>
+          <a:lnRef idx="1">
+            <a:schemeClr val="accent1"/>
+          </a:lnRef>
+          <a:fillRef idx="3">
+            <a:schemeClr val="accent1"/>
+          </a:fillRef>
+          <a:effectRef idx="2">
+            <a:schemeClr val="accent1"/>
+          </a:effectRef>
+          <a:fontRef idx="minor">
+            <a:schemeClr val="lt1"/>
+          </a:fontRef>
+        </p:style>
+        <p:txBody>
+          <a:bodyPr rtlCol="0" anchor="ctr"/>
+          <a:lstStyle/>
+          <a:p>
+            <a:pPr algn="ctr"/>
+          </a:p>
+        </p:txBody>
+      </p:sp>
+      <p:sp>
+        <p:nvSpPr>
+          <p:cNvPr id="20" name="TextBox 19"/>
+          <p:cNvSpPr txBox="1"/>
+          <p:nvPr/>
+        </p:nvSpPr>
+        <p:spPr>
+          <a:xfrm>
+            <a:off x="8183880" y="1828800"/>
+            <a:ext cx="3337560" cy="1965960"/>
+          </a:xfrm>
+          <a:prstGeom prst="rect">
+            <a:avLst/>
+          </a:prstGeom>
+          <a:noFill/>
+        </p:spPr>
+        <p:txBody>
+          <a:bodyPr wrap="square">
+            <a:spAutoFit/>
+          </a:bodyPr>
+          <a:lstStyle/>
           <a:p>
             <a:pPr algn="l">
               <a:lnSpc>
@@ -38954,7 +39173,7 @@
               </a:defRPr>
             </a:pPr>
             <a:r>
-              <a:t>● mGear：开源模块化绑定框架</a:t>
+              <a:t>● Quick Rig：一键式人形自动绑定</a:t>
             </a:r>
           </a:p>
           <a:p>
@@ -38973,7 +39192,7 @@
               </a:defRPr>
             </a:pPr>
             <a:r>
-              <a:t>● 影视/游戏行业广泛使用</a:t>
+              <a:t>● mGear：开源模块化绑定框架</a:t>
             </a:r>
           </a:p>
           <a:p>
@@ -38986,13 +39205,13 @@
               </a:spcAft>
               <a:defRPr sz="1100" b="0">
                 <a:solidFill>
-                  <a:srgbClr val="00B4D8"/>
-                </a:solidFill>
-                <a:latin typeface="Microsoft YaHei"/>
-              </a:defRPr>
-            </a:pPr>
-            <a:r>
-              <a:t>● mGear已成为事实标准</a:t>
+                  <a:srgbClr val="FFFFFF"/>
+                </a:solidFill>
+                <a:latin typeface="Microsoft YaHei"/>
+              </a:defRPr>
+            </a:pPr>
+            <a:r>
+              <a:t>● 影视/游戏行业广泛使用</a:t>
             </a:r>
           </a:p>
           <a:p>
@@ -39005,13 +39224,32 @@
               </a:spcAft>
               <a:defRPr sz="1100" b="0">
                 <a:solidFill>
+                  <a:srgbClr val="00B4D8"/>
+                </a:solidFill>
+                <a:latin typeface="Microsoft YaHei"/>
+              </a:defRPr>
+            </a:pPr>
+            <a:r>
+              <a:t>● mGear已成为事实标准</a:t>
+            </a:r>
+          </a:p>
+          <a:p>
+            <a:pPr algn="l">
+              <a:lnSpc>
+                <a:spcPct val="125000"/>
+              </a:lnSpc>
+              <a:spcAft>
+                <a:spcPts val="300"/>
+              </a:spcAft>
+              <a:defRPr sz="1100" b="0">
+                <a:solidFill>
                   <a:srgbClr val="707088"/>
                 </a:solidFill>
                 <a:latin typeface="Microsoft YaHei"/>
               </a:defRPr>
             </a:pPr>
             <a:r>
-              <a:t>● 无AI绑定方案</a:t>
+              <a:t>● Maya内置，工业标准蒙皮方案</a:t>
             </a:r>
           </a:p>
         </p:txBody>
@@ -39582,7 +39820,7 @@
                         </a:defRPr>
                       </a:pPr>
                       <a:r>
-                        <a:t>无AI方案，Autodesk Research正在探索</a:t>
+                        <a:t>无AI方案，Autodesk正探索AI绑定方向</a:t>
                       </a:r>
                     </a:p>
                   </a:txBody>
@@ -42368,7 +42606,7 @@
               </a:defRPr>
             </a:pPr>
             <a:r>
-              <a:t>● 支持人形 + 四足自动绑定，500+内置动画库</a:t>
+              <a:t>● 支持人形 + 四足自动绑定，Pro计划500+动画库</a:t>
             </a:r>
           </a:p>
           <a:p>
@@ -42406,7 +42644,7 @@
               </a:defRPr>
             </a:pPr>
             <a:r>
-              <a:t>● Smart Remesh改善模型拓扑以提升绑定质量</a:t>
+              <a:t>● Smart Remesh改善拓扑以提升绑定质量</a:t>
             </a:r>
           </a:p>
           <a:p>
@@ -42425,7 +42663,7 @@
               </a:defRPr>
             </a:pPr>
             <a:r>
-              <a:t>● 插件支持：Blender/Unity/UE/Maya/Godot</a:t>
+              <a:t>● 插件：Blender/Unity/UE/Maya/Godot</a:t>
             </a:r>
           </a:p>
           <a:p>
@@ -42444,7 +42682,7 @@
               </a:defRPr>
             </a:pPr>
             <a:r>
-              <a:t>● 商业模式：SaaS ($20/月起) + REST API</a:t>
+              <a:t>● 商业：SaaS ($20/月起) + REST API</a:t>
             </a:r>
           </a:p>
           <a:p>
@@ -42463,7 +42701,7 @@
               </a:defRPr>
             </a:pPr>
             <a:r>
-              <a:t>● G2评分4.8/5，合作伙伴：Nexon/Supercell/Square Enix/Meta</a:t>
+              <a:t>● G2 4.8/5，合作：Nexon/Supercell/Square Enix/Meta</a:t>
             </a:r>
           </a:p>
           <a:p>
@@ -42517,7 +42755,7 @@
               </a:defRPr>
             </a:pPr>
             <a:r>
-              <a:t>优势：3D生成到绑定动画一条龙  局限：AI生成模型拓扑影响绑定精度</a:t>
+              <a:t>优势：3D生成到绑定动画一条龙  局限：AI生成拓扑影响绑定精度</a:t>
             </a:r>
           </a:p>
         </p:txBody>
@@ -42638,7 +42876,7 @@
               </a:defRPr>
             </a:pPr>
             <a:r>
-              <a:t>● 核心路线：AI + 规则混合</a:t>
+              <a:t>● 核心路线：AI + 规则混合（源自Stanford University研究）</a:t>
             </a:r>
           </a:p>
           <a:p>
@@ -42733,7 +42971,7 @@
               </a:defRPr>
             </a:pPr>
             <a:r>
-              <a:t>● 完全免费（Adobe CC订阅用户）</a:t>
+              <a:t>● 免费使用（需注册Adobe ID，无需付费订阅）</a:t>
             </a:r>
           </a:p>
           <a:p>
@@ -43277,7 +43515,7 @@
                         </a:defRPr>
                       </a:pPr>
                       <a:r>
-                        <a:t>500+</a:t>
+                        <a:t>Pro 500+</a:t>
                       </a:r>
                     </a:p>
                   </a:txBody>

</xml_diff>

<commit_message>
Auto-Rigging v5.1 - fix 13 page number errors + remove 96-480x residual
</commit_message>
<xml_diff>
--- a/Auto-Rigging-Insight-Report.pptx
+++ b/Auto-Rigging-Insight-Report.pptx
@@ -9994,7 +9994,7 @@
               </a:defRPr>
             </a:pPr>
             <a:r>
-              <a:t>18/27</a:t>
+              <a:t>12/27</a:t>
             </a:r>
           </a:p>
         </p:txBody>
@@ -12162,7 +12162,7 @@
               </a:defRPr>
             </a:pPr>
             <a:r>
-              <a:t>25/27</a:t>
+              <a:t>13/27</a:t>
             </a:r>
           </a:p>
         </p:txBody>
@@ -15143,7 +15143,7 @@
               </a:defRPr>
             </a:pPr>
             <a:r>
-              <a:t>18/27</a:t>
+              <a:t>14/27</a:t>
             </a:r>
           </a:p>
         </p:txBody>
@@ -17964,7 +17964,7 @@
               </a:defRPr>
             </a:pPr>
             <a:r>
-              <a:t>25/27</a:t>
+              <a:t>15/27</a:t>
             </a:r>
           </a:p>
         </p:txBody>
@@ -20209,7 +20209,7 @@
               </a:defRPr>
             </a:pPr>
             <a:r>
-              <a:t>18/27</a:t>
+              <a:t>16/27</a:t>
             </a:r>
           </a:p>
         </p:txBody>
@@ -23326,7 +23326,7 @@
               </a:defRPr>
             </a:pPr>
             <a:r>
-              <a:t>25/27</a:t>
+              <a:t>17/27</a:t>
             </a:r>
           </a:p>
         </p:txBody>
@@ -29400,7 +29400,7 @@
               </a:defRPr>
             </a:pPr>
             <a:r>
-              <a:t>25/27</a:t>
+              <a:t>19/27</a:t>
             </a:r>
           </a:p>
         </p:txBody>
@@ -32679,7 +32679,7 @@
               </a:defRPr>
             </a:pPr>
             <a:r>
-              <a:t>26/27</a:t>
+              <a:t>20/27</a:t>
             </a:r>
           </a:p>
         </p:txBody>
@@ -35321,7 +35321,7 @@
               </a:defRPr>
             </a:pPr>
             <a:r>
-              <a:t>27/27</a:t>
+              <a:t>21/27</a:t>
             </a:r>
           </a:p>
         </p:txBody>
@@ -37762,7 +37762,7 @@
               </a:defRPr>
             </a:pPr>
             <a:r>
-              <a:t>25/27</a:t>
+              <a:t>22/27</a:t>
             </a:r>
           </a:p>
         </p:txBody>
@@ -40235,7 +40235,7 @@
               </a:defRPr>
             </a:pPr>
             <a:r>
-              <a:t>26/27</a:t>
+              <a:t>23/27</a:t>
             </a:r>
           </a:p>
         </p:txBody>
@@ -42507,7 +42507,7 @@
               </a:defRPr>
             </a:pPr>
             <a:r>
-              <a:t>27/27</a:t>
+              <a:t>24/27</a:t>
             </a:r>
           </a:p>
         </p:txBody>
@@ -51598,7 +51598,7 @@
               </a:defRPr>
             </a:pPr>
             <a:r>
-              <a:t>● 纯自动时间提升96-480x（不含精修）</a:t>
+              <a:t>● 纯自动阶段仅占完整流程1-3%，精修才是主要耗时</a:t>
             </a:r>
           </a:p>
         </p:txBody>

</xml_diff>